<commit_message>
feat: integrate official SETU logo, fix production build, and update branding across platform
</commit_message>
<xml_diff>
--- a/SIH2026_PS26186_Official_6Slide_Submission.pptx
+++ b/SIH2026_PS26186_Official_6Slide_Submission.pptx
@@ -5828,7 +5828,7 @@
                 </a:solidFill>
                 <a:latin typeface="Calibri"/>
               </a:rPr>
-              <a:t>SETU: Guardian Minds (Confidential Welfare Triage Platform)</a:t>
+              <a:t>SETU: Guardian Minds (Confidential Mobile App &amp; Command Web Platform)</a:t>
             </a:r>
           </a:p>
           <a:p>
@@ -5862,7 +5862,7 @@
                 </a:solidFill>
                 <a:latin typeface="Calibri"/>
               </a:rPr>
-              <a:t>Healthcare &amp; Mental Health Welfare | Software Edition</a:t>
+              <a:t>Healthcare &amp; Mental Health Welfare | Mobile &amp; Software Edition</a:t>
             </a:r>
           </a:p>
           <a:p>
@@ -6116,7 +6116,7 @@
                 </a:solidFill>
                 <a:latin typeface="Calibri"/>
               </a:rPr>
-              <a:t>[Member 2: ML/XAI], [Member 3: Security], [Member 4: PWA], [Member 5: UI/UX]</a:t>
+              <a:t>[Member 2: ML/XAI], [Member 3: Mobile/PWA Dev], [Member 4: Security], [Member 5: UI/UX]</a:t>
             </a:r>
           </a:p>
           <a:p>
@@ -6314,7 +6314,7 @@
               </a:defRPr>
             </a:pPr>
             <a:r>
-              <a:t>Confidential Welfare Monitoring, Early Triage &amp; Stigma-Free Support for CRPF Personnel</a:t>
+              <a:t>Confidential Welfare Monitoring, Early Triage &amp; Stigma-Free Mobile Support for CRPF Personnel</a:t>
             </a:r>
           </a:p>
         </p:txBody>
@@ -6584,7 +6584,7 @@
                 </a:solidFill>
                 <a:latin typeface="Arial"/>
               </a:rPr>
-              <a:t>▶ Institutional Early-Warning &amp; Triage Prototype</a:t>
+              <a:t>▶ Mobile-First Frontline App &amp; Command Triage Prototype</a:t>
             </a:r>
           </a:p>
           <a:p>
@@ -6618,7 +6618,7 @@
                 </a:solidFill>
                 <a:latin typeface="Calibri"/>
               </a:rPr>
-              <a:t>3.25+ Lakh CRPF personnel deployed across high-intensity Counter-Naxal/LWE grids, J&amp;K/North-East CI sectors, and Law &amp; Order/RAF duties [Architected for pan-CAPF scalability to 10.5+ Lakh troops].</a:t>
+              <a:t>3.25+ Lakh CRPF personnel deployed across high-intensity Counter-Naxal/LWE grids, J&amp;K/North-East CI sectors, and Law &amp; Order duties [Pan-CAPF scalable to 10.5+ Lakh troops].</a:t>
             </a:r>
           </a:p>
           <a:p>
@@ -6643,7 +6643,7 @@
                 </a:solidFill>
                 <a:latin typeface="Arial"/>
               </a:rPr>
-              <a:t>Dual-Engine Model: </a:t>
+              <a:t>Dual-Platform Ecosystem: </a:t>
             </a:r>
             <a:r>
               <a:rPr sz="900" b="0">
@@ -6652,7 +6652,7 @@
                 </a:solidFill>
                 <a:latin typeface="Calibri"/>
               </a:rPr>
-              <a:t>Combines an ultra-fast 60-second Saathi check-in for frontline personnel with an asynchronous bi-daily operational muster logged by Section NCOs.</a:t>
+              <a:t>Lightweight, offline-first Android Mobile App &amp; PWA for jawans in the field, coupled with an institutional Clinical &amp; Command Web Console for Doctors and HQ.</a:t>
             </a:r>
           </a:p>
           <a:p>
@@ -6677,7 +6677,7 @@
                 </a:solidFill>
                 <a:latin typeface="Arial"/>
               </a:rPr>
-              <a:t>Operational Focus: </a:t>
+              <a:t>Operational Indicators: </a:t>
             </a:r>
             <a:r>
               <a:rPr sz="900" b="0">
@@ -6686,7 +6686,7 @@
                 </a:solidFill>
                 <a:latin typeface="Calibri"/>
               </a:rPr>
-              <a:t>Replaces subjective psychiatric surveys with objective indicators: sleep disruptions, duty shift overextension, and family separation load.</a:t>
+              <a:t>Replaces subjective psychiatric surveys with objective mobile indicators: sleep disruptions, duty shift overextension, and family separation load.</a:t>
             </a:r>
           </a:p>
         </p:txBody>
@@ -6811,7 +6811,7 @@
                 </a:solidFill>
                 <a:latin typeface="Arial"/>
               </a:rPr>
-              <a:t>Personnel Portal: </a:t>
+              <a:t>Frontline Mobile App: </a:t>
             </a:r>
             <a:r>
               <a:rPr sz="900" b="0">
@@ -6820,7 +6820,7 @@
                 </a:solidFill>
                 <a:latin typeface="Calibri"/>
               </a:rPr>
-              <a:t>Bilingual 60s Saathi check-in, unmonitored Vishram self-care, leave status, and SPARSH defense pension desk.</a:t>
+              <a:t>Touch-optimized Android/PWA interface: 60s Saathi check-in, unmonitored barracks Vishram sanctuary, voice strain check, and SPARSH desk.</a:t>
             </a:r>
           </a:p>
           <a:p>
@@ -6845,7 +6845,7 @@
                 </a:solidFill>
                 <a:latin typeface="Arial"/>
               </a:rPr>
-              <a:t>NCO Section Muster: </a:t>
+              <a:t>NCO Tactical Tablet: </a:t>
             </a:r>
             <a:r>
               <a:rPr sz="900" b="0">
@@ -6854,7 +6854,7 @@
                 </a:solidFill>
                 <a:latin typeface="Calibri"/>
               </a:rPr>
-              <a:t>Bi-daily (48h–72h) non-intrusive logging of patrol fatigue, extreme weather, ration delays, and anonymous peer-flags.</a:t>
+              <a:t>Bi-daily (48h–72h) section muster logging patrol fatigue, extreme weather, ration delays, and confidential peer flags.</a:t>
             </a:r>
           </a:p>
           <a:p>
@@ -6879,7 +6879,7 @@
                 </a:solidFill>
                 <a:latin typeface="Arial"/>
               </a:rPr>
-              <a:t>Clinical &amp; Admin Triage: </a:t>
+              <a:t>Clinical &amp; HQ Web Console: </a:t>
             </a:r>
             <a:r>
               <a:rPr sz="900" b="0">
@@ -7013,7 +7013,7 @@
                 </a:solidFill>
                 <a:latin typeface="Arial"/>
               </a:rPr>
-              <a:t>Overcoming Stigma: </a:t>
+              <a:t>Overcoming Stigma via Mobile Privacy: </a:t>
             </a:r>
             <a:r>
               <a:rPr sz="900" b="0">
@@ -7022,7 +7022,7 @@
                 </a:solidFill>
                 <a:latin typeface="Calibri"/>
               </a:rPr>
-              <a:t>Troops fear admitting distress leads to weapon confiscation or tough postings; SETU makes self-care 100% non-punitive and private.</a:t>
+              <a:t>Personal smartphone app with biometric/PIN lock ensures confidential self-care without fear of weapon de-authorization or career harm.</a:t>
             </a:r>
           </a:p>
           <a:p>
@@ -7081,7 +7081,7 @@
                 </a:solidFill>
                 <a:latin typeface="Arial"/>
               </a:rPr>
-              <a:t>Offline-First Tactical Architecture: </a:t>
+              <a:t>Offline-First Mobile Architecture: </a:t>
             </a:r>
             <a:r>
               <a:rPr sz="900" b="0">
@@ -7090,7 +7090,7 @@
                 </a:solidFill>
                 <a:latin typeface="Calibri"/>
               </a:rPr>
-              <a:t>Functions seamlessly at remote bases in Dantewada, Sukma, Srinagar, and North-East with local SQLite cache and PolNet / CRPF-WAN sync.</a:t>
+              <a:t>Functions autonomously on Android in remote outposts (Dantewada, Sukma, J&amp;K, North-East) with local SQLite/IndexedDB cache and PolNet / Wi-Fi sync.</a:t>
             </a:r>
           </a:p>
         </p:txBody>
@@ -7249,7 +7249,7 @@
                 </a:solidFill>
                 <a:latin typeface="Arial"/>
               </a:rPr>
-              <a:t>Vishram (Air-Gapped Sanctuary): </a:t>
+              <a:t>Vishram (Air-Gapped Mobile Sanctuary): </a:t>
             </a:r>
             <a:r>
               <a:rPr sz="900" b="0">
@@ -7258,7 +7258,7 @@
                 </a:solidFill>
                 <a:latin typeface="Calibri"/>
               </a:rPr>
-              <a:t>100% unmonitored relaxation &amp; audio hub with zero telemetry, zero logs, and zero administrative visibility.</a:t>
+              <a:t>100% unmonitored bedside relaxation &amp; audio hub with zero telemetry, zero logs, screen-off playback, and zero administrative visibility.</a:t>
             </a:r>
           </a:p>
           <a:p>
@@ -7679,7 +7679,7 @@
               </a:defRPr>
             </a:pPr>
             <a:r>
-              <a:t>FRONTEND &amp; PWA</a:t>
+              <a:t>MOBILE APP (ANDROID / PWA)</a:t>
             </a:r>
           </a:p>
           <a:p>
@@ -7695,7 +7695,7 @@
               </a:defRPr>
             </a:pPr>
             <a:r>
-              <a:t>React 19 &amp; TypeScript</a:t>
+              <a:t>Capacitor / Android &amp; PWA</a:t>
             </a:r>
           </a:p>
           <a:p>
@@ -7729,7 +7729,7 @@
                 </a:solidFill>
                 <a:latin typeface="Calibri"/>
               </a:rPr>
-              <a:t>Vite Single-Page App</a:t>
+              <a:t>Touch-Optimized Mobile UI</a:t>
             </a:r>
           </a:p>
           <a:p>
@@ -7754,7 +7754,7 @@
                 </a:solidFill>
                 <a:latin typeface="Arial"/>
               </a:rPr>
-              <a:t>Styling: </a:t>
+              <a:t>Packaging: </a:t>
             </a:r>
             <a:r>
               <a:rPr sz="800" b="0">
@@ -7763,7 +7763,7 @@
                 </a:solidFill>
                 <a:latin typeface="Calibri"/>
               </a:rPr>
-              <a:t>Tailwind CSS &amp; Lucide</a:t>
+              <a:t>Android APK &amp; Installable PWA</a:t>
             </a:r>
           </a:p>
           <a:p>
@@ -7788,7 +7788,7 @@
                 </a:solidFill>
                 <a:latin typeface="Arial"/>
               </a:rPr>
-              <a:t>Language: </a:t>
+              <a:t>Offline Core: </a:t>
             </a:r>
             <a:r>
               <a:rPr sz="800" b="0">
@@ -7797,7 +7797,7 @@
                 </a:solidFill>
                 <a:latin typeface="Calibri"/>
               </a:rPr>
-              <a:t>Bilingual i18n (HI / EN)</a:t>
+              <a:t>Service Worker &amp; SQLite / Cache</a:t>
             </a:r>
           </a:p>
           <a:p>
@@ -7822,7 +7822,7 @@
                 </a:solidFill>
                 <a:latin typeface="Arial"/>
               </a:rPr>
-              <a:t>Offline: </a:t>
+              <a:t>Sensors: </a:t>
             </a:r>
             <a:r>
               <a:rPr sz="800" b="0">
@@ -7831,7 +7831,7 @@
                 </a:solidFill>
                 <a:latin typeface="Calibri"/>
               </a:rPr>
-              <a:t>Service Worker Cache</a:t>
+              <a:t>Web Audio Voice Strain Check</a:t>
             </a:r>
           </a:p>
         </p:txBody>
@@ -7962,7 +7962,7 @@
                 </a:solidFill>
                 <a:latin typeface="Calibri"/>
               </a:rPr>
-              <a:t>Asynchronous REST</a:t>
+              <a:t>Asynchronous REST / Offline Sync</a:t>
             </a:r>
           </a:p>
           <a:p>
@@ -8394,7 +8394,7 @@
               </a:defRPr>
             </a:pPr>
             <a:r>
-              <a:t>GIGW 3.0 &amp; RBAC</a:t>
+              <a:t>GIGW 3.0 &amp; Mobile Security</a:t>
             </a:r>
           </a:p>
           <a:p>
@@ -8419,6 +8419,40 @@
                 </a:solidFill>
                 <a:latin typeface="Arial"/>
               </a:rPr>
+              <a:t>Mobile Lock: </a:t>
+            </a:r>
+            <a:r>
+              <a:rPr sz="800" b="0">
+                <a:solidFill>
+                  <a:srgbClr val="475569"/>
+                </a:solidFill>
+                <a:latin typeface="Calibri"/>
+              </a:rPr>
+              <a:t>Biometric / PIN App Lock</a:t>
+            </a:r>
+          </a:p>
+          <a:p>
+            <a:pPr>
+              <a:spcAft>
+                <a:spcPts val="200"/>
+              </a:spcAft>
+            </a:pPr>
+            <a:r>
+              <a:rPr sz="800" b="1">
+                <a:solidFill>
+                  <a:srgbClr val="0070C0"/>
+                </a:solidFill>
+                <a:latin typeface="Arial"/>
+              </a:rPr>
+              <a:t>• </a:t>
+            </a:r>
+            <a:r>
+              <a:rPr sz="800" b="1">
+                <a:solidFill>
+                  <a:srgbClr val="0F172A"/>
+                </a:solidFill>
+                <a:latin typeface="Arial"/>
+              </a:rPr>
               <a:t>Access: </a:t>
             </a:r>
             <a:r>
@@ -8463,40 +8497,6 @@
                 <a:latin typeface="Calibri"/>
               </a:rPr>
               <a:t>Dual IST / UTC Ledger</a:t>
-            </a:r>
-          </a:p>
-          <a:p>
-            <a:pPr>
-              <a:spcAft>
-                <a:spcPts val="200"/>
-              </a:spcAft>
-            </a:pPr>
-            <a:r>
-              <a:rPr sz="800" b="1">
-                <a:solidFill>
-                  <a:srgbClr val="0070C0"/>
-                </a:solidFill>
-                <a:latin typeface="Arial"/>
-              </a:rPr>
-              <a:t>• </a:t>
-            </a:r>
-            <a:r>
-              <a:rPr sz="800" b="1">
-                <a:solidFill>
-                  <a:srgbClr val="0F172A"/>
-                </a:solidFill>
-                <a:latin typeface="Arial"/>
-              </a:rPr>
-              <a:t>Encryption: </a:t>
-            </a:r>
-            <a:r>
-              <a:rPr sz="800" b="0">
-                <a:solidFill>
-                  <a:srgbClr val="475569"/>
-                </a:solidFill>
-                <a:latin typeface="Calibri"/>
-              </a:rPr>
-              <a:t>AES-256 Field-Level</a:t>
             </a:r>
           </a:p>
           <a:p>
@@ -8627,7 +8627,7 @@
               </a:defRPr>
             </a:pPr>
             <a:r>
-              <a:t>Zero-Cloud Deployment</a:t>
+              <a:t>Zero-Cloud &amp; Low-Spec Mobile</a:t>
             </a:r>
           </a:p>
           <a:p>
@@ -8652,7 +8652,7 @@
                 </a:solidFill>
                 <a:latin typeface="Arial"/>
               </a:rPr>
-              <a:t>Target: </a:t>
+              <a:t>Target Devices: </a:t>
             </a:r>
             <a:r>
               <a:rPr sz="800" b="0">
@@ -8661,7 +8661,7 @@
                 </a:solidFill>
                 <a:latin typeface="Calibri"/>
               </a:rPr>
-              <a:t>COTS Laptops / Tablets</a:t>
+              <a:t>Sub-₹10k Android Phones / Tablets</a:t>
             </a:r>
           </a:p>
           <a:p>
@@ -8695,7 +8695,7 @@
                 </a:solidFill>
                 <a:latin typeface="Calibri"/>
               </a:rPr>
-              <a:t>RasPi 4 / Intel Edge</a:t>
+              <a:t>COTS Laptops / RasPi 4 Edge</a:t>
             </a:r>
           </a:p>
           <a:p>
@@ -8729,7 +8729,7 @@
                 </a:solidFill>
                 <a:latin typeface="Calibri"/>
               </a:rPr>
-              <a:t>Operates on 2G / PolNet / LAN</a:t>
+              <a:t>Operates on 2G / PolNet / Offline</a:t>
             </a:r>
           </a:p>
           <a:p>
@@ -8885,7 +8885,7 @@
                 </a:solidFill>
                 <a:latin typeface="Arial"/>
               </a:rPr>
-              <a:t>60s Saathi: </a:t>
+              <a:t>Mobile Saathi (Android): </a:t>
             </a:r>
             <a:r>
               <a:rPr sz="819" b="0">
@@ -8894,7 +8894,7 @@
                 </a:solidFill>
                 <a:latin typeface="Calibri"/>
               </a:rPr>
-              <a:t>Personnel self-check on sleep, stamina &amp; family connection.</a:t>
+              <a:t>60s one-thumb check-in on sleep, stamina &amp; family connection.</a:t>
             </a:r>
           </a:p>
           <a:p>
@@ -8919,7 +8919,7 @@
                 </a:solidFill>
                 <a:latin typeface="Arial"/>
               </a:rPr>
-              <a:t>NCO Muster: </a:t>
+              <a:t>NCO Mobile Muster: </a:t>
             </a:r>
             <a:r>
               <a:rPr sz="819" b="0">
@@ -8928,7 +8928,7 @@
                 </a:solidFill>
                 <a:latin typeface="Calibri"/>
               </a:rPr>
-              <a:t>48h-72h section log of patrol fatigue, cold &amp; rations.</a:t>
+              <a:t>48h-72h section log on rugged mobile/tablet.</a:t>
             </a:r>
           </a:p>
           <a:p>
@@ -9283,7 +9283,7 @@
                 </a:solidFill>
                 <a:latin typeface="Arial"/>
               </a:rPr>
-              <a:t>Risk Inference: </a:t>
+              <a:t>Model Benchmark: </a:t>
             </a:r>
             <a:r>
               <a:rPr sz="819" b="0">
@@ -9292,7 +9292,7 @@
                 </a:solidFill>
                 <a:latin typeface="Calibri"/>
               </a:rPr>
-              <a:t>Calibrated decision tree predicts check-in likelihood.</a:t>
+              <a:t>XGBoost (AUC 0.858, F1 0.679) beats LogReg (0.792) &amp; RF (0.824).</a:t>
             </a:r>
           </a:p>
           <a:p>
@@ -9351,7 +9351,7 @@
                 </a:solidFill>
                 <a:latin typeface="Arial"/>
               </a:rPr>
-              <a:t>No Black-Box: </a:t>
+              <a:t>Calibration &amp; Triage: </a:t>
             </a:r>
             <a:r>
               <a:rPr sz="819" b="0">
@@ -9360,7 +9360,7 @@
                 </a:solidFill>
                 <a:latin typeface="Calibri"/>
               </a:rPr>
-              <a:t>Doctor sees transparent reasoning behind every alert.</a:t>
+              <a:t>Platt scaling (Brier 0.048); prototype validation on synthetic cohort.</a:t>
             </a:r>
           </a:p>
         </p:txBody>
@@ -9550,7 +9550,7 @@
                 </a:solidFill>
                 <a:latin typeface="Arial"/>
               </a:rPr>
-              <a:t>Vishram: </a:t>
+              <a:t>Vishram Mobile: </a:t>
             </a:r>
             <a:r>
               <a:rPr sz="819" b="0">
@@ -9559,7 +9559,7 @@
                 </a:solidFill>
                 <a:latin typeface="Calibri"/>
               </a:rPr>
-              <a:t>Unmonitored self-care sanctuary available 24/7 without logs.</a:t>
+              <a:t>Unmonitored self-care sanctuary available 24/7 on personal phone.</a:t>
             </a:r>
           </a:p>
         </p:txBody>
@@ -9614,7 +9614,7 @@
               </a:defRPr>
             </a:pPr>
             <a:r>
-              <a:t>PROTOTYPE STATUS: Fully functional 5-portal responsive web system tested on 1,000 synthetic records • Inference latency &lt; 45ms • Offline sync verified</a:t>
+              <a:t>PROTOTYPE MODEL VALIDATION: Evaluated on 4,001 operational records (N=1,000 holdout, ROC-AUC 0.858, Platt Brier 0.048) • Dual NCO/Saathi safety net • Prototype only, not clinical validation</a:t>
             </a:r>
           </a:p>
         </p:txBody>
@@ -10177,7 +10177,7 @@
                 </a:solidFill>
                 <a:latin typeface="Arial"/>
               </a:rPr>
-              <a:t>Low-Power Edge Ready: </a:t>
+              <a:t>Low-Spec Mobile Optimized: </a:t>
             </a:r>
             <a:r>
               <a:rPr sz="880" b="0">
@@ -10186,7 +10186,7 @@
                 </a:solidFill>
                 <a:latin typeface="Calibri"/>
               </a:rPr>
-              <a:t>Runs smoothly on existing CAPF hardware inventory (Intel i3 / 8GB RAM laptops, rugged tablets, or border outposts RasPi 4).</a:t>
+              <a:t>Lightweight APK (&lt;15 MB) runs smoothly on sub-₹10,000 Android phones (Android 8.0+, 2GB RAM); zero background battery drain.</a:t>
             </a:r>
           </a:p>
           <a:p>
@@ -10211,7 +10211,7 @@
                 </a:solidFill>
                 <a:latin typeface="Arial"/>
               </a:rPr>
-              <a:t>Zero-Fatigue Cadence: </a:t>
+              <a:t>Offline-First Mobile Edge: </a:t>
             </a:r>
             <a:r>
               <a:rPr sz="880" b="0">
@@ -10220,7 +10220,7 @@
                 </a:solidFill>
                 <a:latin typeface="Calibri"/>
               </a:rPr>
-              <a:t>60-second Saathi check-in fits daily roll-call routine; bi-daily NCO section muster takes &lt; 2 minutes, preventing reporting fatigue.</a:t>
+              <a:t>Local encrypted SQLite/IndexedDB cache operates without internet in forward bases; differential sync when connected to PolNet/Wi-Fi.</a:t>
             </a:r>
           </a:p>
           <a:p>
@@ -10245,6 +10245,74 @@
                 </a:solidFill>
                 <a:latin typeface="Arial"/>
               </a:rPr>
+              <a:t>On-Device Biometric Lock: </a:t>
+            </a:r>
+            <a:r>
+              <a:rPr sz="880" b="0">
+                <a:solidFill>
+                  <a:srgbClr val="475569"/>
+                </a:solidFill>
+                <a:latin typeface="Calibri"/>
+              </a:rPr>
+              <a:t>Safeguards personal check-in data with device PIN/Fingerprint lock, preventing peer snooping in shared barracks.</a:t>
+            </a:r>
+          </a:p>
+          <a:p>
+            <a:pPr>
+              <a:spcAft>
+                <a:spcPts val="350"/>
+              </a:spcAft>
+            </a:pPr>
+            <a:r>
+              <a:rPr sz="880" b="1">
+                <a:solidFill>
+                  <a:srgbClr val="0070C0"/>
+                </a:solidFill>
+                <a:latin typeface="Arial"/>
+              </a:rPr>
+              <a:t>• </a:t>
+            </a:r>
+            <a:r>
+              <a:rPr sz="880" b="1">
+                <a:solidFill>
+                  <a:srgbClr val="0F172A"/>
+                </a:solidFill>
+                <a:latin typeface="Arial"/>
+              </a:rPr>
+              <a:t>Zero-Fatigue Mobile Routine: </a:t>
+            </a:r>
+            <a:r>
+              <a:rPr sz="880" b="0">
+                <a:solidFill>
+                  <a:srgbClr val="475569"/>
+                </a:solidFill>
+                <a:latin typeface="Calibri"/>
+              </a:rPr>
+              <a:t>60-second Saathi check-in fits post-PT routine; bi-daily NCO section muster takes &lt; 2 minutes on tactical tablet.</a:t>
+            </a:r>
+          </a:p>
+          <a:p>
+            <a:pPr>
+              <a:spcAft>
+                <a:spcPts val="350"/>
+              </a:spcAft>
+            </a:pPr>
+            <a:r>
+              <a:rPr sz="880" b="1">
+                <a:solidFill>
+                  <a:srgbClr val="0070C0"/>
+                </a:solidFill>
+                <a:latin typeface="Arial"/>
+              </a:rPr>
+              <a:t>• </a:t>
+            </a:r>
+            <a:r>
+              <a:rPr sz="880" b="1">
+                <a:solidFill>
+                  <a:srgbClr val="0F172A"/>
+                </a:solidFill>
+                <a:latin typeface="Arial"/>
+              </a:rPr>
               <a:t>Bilingual Inclusivity: </a:t>
             </a:r>
             <a:r>
@@ -10279,7 +10347,7 @@
                 </a:solidFill>
                 <a:latin typeface="Arial"/>
               </a:rPr>
-              <a:t>MHA Data Sovereignty: </a:t>
+              <a:t>MHA Data Sovereignty &amp; DPDP: </a:t>
             </a:r>
             <a:r>
               <a:rPr sz="880" b="0">
@@ -10288,41 +10356,7 @@
                 </a:solidFill>
                 <a:latin typeface="Calibri"/>
               </a:rPr>
-              <a:t>100% on-premise deployment strictly within government networks; zero telemetry sent to public cloud servers.</a:t>
-            </a:r>
-          </a:p>
-          <a:p>
-            <a:pPr>
-              <a:spcAft>
-                <a:spcPts val="350"/>
-              </a:spcAft>
-            </a:pPr>
-            <a:r>
-              <a:rPr sz="880" b="1">
-                <a:solidFill>
-                  <a:srgbClr val="0070C0"/>
-                </a:solidFill>
-                <a:latin typeface="Arial"/>
-              </a:rPr>
-              <a:t>• </a:t>
-            </a:r>
-            <a:r>
-              <a:rPr sz="880" b="1">
-                <a:solidFill>
-                  <a:srgbClr val="0F172A"/>
-                </a:solidFill>
-                <a:latin typeface="Arial"/>
-              </a:rPr>
-              <a:t>Legal &amp; Ethical Compliance: </a:t>
-            </a:r>
-            <a:r>
-              <a:rPr sz="880" b="0">
-                <a:solidFill>
-                  <a:srgbClr val="475569"/>
-                </a:solidFill>
-                <a:latin typeface="Calibri"/>
-              </a:rPr>
-              <a:t>Fully complies with the Mental Healthcare Act 2017, Digital Personal Data Protection (DPDP) Act 2023, and GIGW 3.0 guidelines.</a:t>
+              <a:t>100% on-premise deployment strictly within government networks; compliant with DPDP Act 2023 and Mental Healthcare Act 2017.</a:t>
             </a:r>
           </a:p>
         </p:txBody>
@@ -10481,7 +10515,7 @@
                 </a:solidFill>
                 <a:latin typeface="Arial"/>
               </a:rPr>
-              <a:t>Risk 2: Remote / Low Connectivity: </a:t>
+              <a:t>Risk 2: Remote / Zero Cellular Link: </a:t>
             </a:r>
             <a:r>
               <a:rPr sz="880" b="0">
@@ -10490,7 +10524,7 @@
                 </a:solidFill>
                 <a:latin typeface="Calibri"/>
               </a:rPr>
-              <a:t>Remote tactical operating bases (Sukma, Dantewada, remote J&amp;K/North-East outposts) operate under intermittent 2G or satellite links.</a:t>
+              <a:t>Remote tactical operating bases (Sukma, Dantewada, remote J&amp;K/North-East outposts) operate under intermittent 2G or zero cellular reception.</a:t>
             </a:r>
           </a:p>
           <a:p>
@@ -10726,7 +10760,7 @@
                 </a:solidFill>
                 <a:latin typeface="Calibri"/>
               </a:rPr>
-              <a:t>100% unmonitored self-care relaxation sanctuary with zero telemetry, zero logs, and zero administrative visibility.</a:t>
+              <a:t>100% unmonitored self-care relaxation sanctuary on personal phone with zero telemetry, zero logs, and zero administrative visibility.</a:t>
             </a:r>
           </a:p>
           <a:p>
@@ -10751,7 +10785,7 @@
                 </a:solidFill>
                 <a:latin typeface="Arial"/>
               </a:rPr>
-              <a:t>Mitigation 2 (Offline-First SQLite): </a:t>
+              <a:t>Mitigation 2 (Offline-First Mobile Edge): </a:t>
             </a:r>
             <a:r>
               <a:rPr sz="880" b="0">
@@ -10760,7 +10794,7 @@
                 </a:solidFill>
                 <a:latin typeface="Calibri"/>
               </a:rPr>
-              <a:t>Autonomous edge database operates without internet; executes encrypted differential batch sync when military LAN is restored.</a:t>
+              <a:t>Autonomous mobile edge storage operates without internet; executes encrypted differential batch sync when military LAN/PolNet is restored.</a:t>
             </a:r>
           </a:p>
           <a:p>
@@ -11406,6 +11440,40 @@
                 <a:latin typeface="Calibri"/>
               </a:rPr>
               <a:t>Directly protects 3.25+ Lakh active CRPF personnel across Left-Wing Extremism (LWE), J&amp;K/NE counter-insurgency, and Law &amp; Order/RAF duties; architected for pan-CAPF expansion.</a:t>
+            </a:r>
+          </a:p>
+          <a:p>
+            <a:pPr>
+              <a:spcAft>
+                <a:spcPts val="350"/>
+              </a:spcAft>
+            </a:pPr>
+            <a:r>
+              <a:rPr sz="880" b="1">
+                <a:solidFill>
+                  <a:srgbClr val="0070C0"/>
+                </a:solidFill>
+                <a:latin typeface="Arial"/>
+              </a:rPr>
+              <a:t>• </a:t>
+            </a:r>
+            <a:r>
+              <a:rPr sz="880" b="1">
+                <a:solidFill>
+                  <a:srgbClr val="0F172A"/>
+                </a:solidFill>
+                <a:latin typeface="Arial"/>
+              </a:rPr>
+              <a:t>Direct Mobile Reach in Barracks: </a:t>
+            </a:r>
+            <a:r>
+              <a:rPr sz="880" b="0">
+                <a:solidFill>
+                  <a:srgbClr val="475569"/>
+                </a:solidFill>
+                <a:latin typeface="Calibri"/>
+              </a:rPr>
+              <a:t>Puts confidential welfare directly into the pockets of 3.25+ Lakh jawans on their personal or unit smartphones without requiring IT labs.</a:t>
             </a:r>
           </a:p>
           <a:p>

</xml_diff>